<commit_message>
docs(comms): deck edits — temporary-solution note + full approver name
- Slide 2 "Why this matters": add bullet noting this is a temporary solution and
  PTVI should prepare the long-term (real) solution ASAP.
- Use the approver's full name "Maman Ashari Hasan Tjokke" consistently (slides 7 & 9).
- Nudge slide-2 body to size 16 / gap 10 so the 6th bullet fits; no overflow.

Co-Authored-By: Claude Opus 4.8 (1M context) <noreply@anthropic.com>
</commit_message>
<xml_diff>
--- a/docs/COMMs-Website-Update-Workflow.pptx
+++ b/docs/COMMs-Website-Update-Workflow.pptx
@@ -3806,11 +3806,11 @@
                 <a:spcPct val="105000"/>
               </a:lnSpc>
               <a:spcAft>
-                <a:spcPts val="1200"/>
+                <a:spcPts val="1000"/>
               </a:spcAft>
             </a:pPr>
             <a:r>
-              <a:rPr sz="1700">
+              <a:rPr sz="1600">
                 <a:solidFill>
                   <a:srgbClr val="2B2B2B"/>
                 </a:solidFill>
@@ -3825,11 +3825,11 @@
                 <a:spcPct val="105000"/>
               </a:lnSpc>
               <a:spcAft>
-                <a:spcPts val="1200"/>
+                <a:spcPts val="1000"/>
               </a:spcAft>
             </a:pPr>
             <a:r>
-              <a:rPr sz="1700">
+              <a:rPr sz="1600">
                 <a:solidFill>
                   <a:srgbClr val="2B2B2B"/>
                 </a:solidFill>
@@ -3844,11 +3844,11 @@
                 <a:spcPct val="105000"/>
               </a:lnSpc>
               <a:spcAft>
-                <a:spcPts val="1200"/>
+                <a:spcPts val="1000"/>
               </a:spcAft>
             </a:pPr>
             <a:r>
-              <a:rPr sz="1700">
+              <a:rPr sz="1600">
                 <a:solidFill>
                   <a:srgbClr val="2B2B2B"/>
                 </a:solidFill>
@@ -3863,11 +3863,11 @@
                 <a:spcPct val="105000"/>
               </a:lnSpc>
               <a:spcAft>
-                <a:spcPts val="1200"/>
+                <a:spcPts val="1000"/>
               </a:spcAft>
             </a:pPr>
             <a:r>
-              <a:rPr sz="1700">
+              <a:rPr sz="1600">
                 <a:solidFill>
                   <a:srgbClr val="2B2B2B"/>
                 </a:solidFill>
@@ -3882,17 +3882,36 @@
                 <a:spcPct val="105000"/>
               </a:lnSpc>
               <a:spcAft>
-                <a:spcPts val="1200"/>
+                <a:spcPts val="1000"/>
               </a:spcAft>
             </a:pPr>
             <a:r>
-              <a:rPr sz="1700">
+              <a:rPr sz="1600">
                 <a:solidFill>
                   <a:srgbClr val="2B2B2B"/>
                 </a:solidFill>
                 <a:latin typeface="Calibri"/>
               </a:rPr>
               <a:t>•  Every change is previewed and signed off before it goes public.</a:t>
+            </a:r>
+          </a:p>
+          <a:p>
+            <a:pPr>
+              <a:lnSpc>
+                <a:spcPct val="105000"/>
+              </a:lnSpc>
+              <a:spcAft>
+                <a:spcPts val="1000"/>
+              </a:spcAft>
+            </a:pPr>
+            <a:r>
+              <a:rPr sz="1600">
+                <a:solidFill>
+                  <a:srgbClr val="2B2B2B"/>
+                </a:solidFill>
+                <a:latin typeface="Calibri"/>
+              </a:rPr>
+              <a:t>•  This is a temporary solution — PTVI should prepare for the real (long-term) solution as soon as possible.</a:t>
             </a:r>
           </a:p>
         </p:txBody>
@@ -9121,7 +9140,7 @@
                 </a:solidFill>
                 <a:latin typeface="Calibri"/>
               </a:rPr>
-              <a:t>•  Confirm the approver flow with Maman on the first go-live.</a:t>
+              <a:t>•  Confirm the approver flow with Maman Ashari Hasan Tjokke on the first go-live.</a:t>
             </a:r>
           </a:p>
           <a:p>

</xml_diff>

<commit_message>
docs(comms): deck — describe visual editor (slide 6) + full approver name (slide 8)
- Slide 6 "New page — the easy way": update steps to the visual editor experience
  (double-click to open in browser, click text/images to edit, Save changes) —
  matches the runbook + COMMs guide, replacing the old "content file" wording.
- Slide 8: spell out "Maman Ashari Hasan Tjokke" (was bare "Tjokke"). No bare
  mentions remain.

Co-Authored-By: Claude Opus 4.8 (1M context) <noreply@anthropic.com>
</commit_message>
<xml_diff>
--- a/docs/COMMs-Website-Update-Workflow.pptx
+++ b/docs/COMMs-Website-Update-Workflow.pptx
@@ -7115,7 +7115,7 @@
                 </a:solidFill>
                 <a:latin typeface="Calibri"/>
               </a:rPr>
-              <a:t>GDI sends you back a simple content file (text + images) from that page.</a:t>
+              <a:t>GDI sends you an editable page — double-click to open it in your browser.</a:t>
             </a:r>
           </a:p>
         </p:txBody>
@@ -7209,7 +7209,7 @@
                 </a:solidFill>
                 <a:latin typeface="Calibri"/>
               </a:rPr>
-              <a:t>You edit the words and swap images — nothing technical.</a:t>
+              <a:t>Click text to type, click images to swap, then hit “Save changes”.</a:t>
             </a:r>
           </a:p>
         </p:txBody>
@@ -8729,7 +8729,7 @@
                 </a:solidFill>
                 <a:latin typeface="Calibri"/>
               </a:rPr>
-              <a:t>•  First COMMs request done end-to-end: homepage domain-change popup (Tjokke).</a:t>
+              <a:t>•  First COMMs request done end-to-end: homepage domain-change popup (Maman Ashari Hasan Tjokke).</a:t>
             </a:r>
           </a:p>
           <a:p>

</xml_diff>

<commit_message>
docs(comms): deck — reinforce that every change is previewed on dev first
Make the dev-preview-then-approve guarantee consistent across slides:
- Slide 2 bullet: "previewed on the dev site and approved before it goes live".
- Slide 3 flow: "Dev preview / review on the dev site" → "Approver / approves the
  preview" → "publishes to live".
- (Slide 7 already stated "signs off on the dev preview before go-live".)

Co-Authored-By: Claude Opus 4.8 (1M context) <noreply@anthropic.com>
</commit_message>
<xml_diff>
--- a/docs/COMMs-Website-Update-Workflow.pptx
+++ b/docs/COMMs-Website-Update-Workflow.pptx
@@ -3892,7 +3892,7 @@
                 </a:solidFill>
                 <a:latin typeface="Calibri"/>
               </a:rPr>
-              <a:t>•  Every change is previewed and signed off before it goes public.</a:t>
+              <a:t>•  Every change is previewed on the dev site and approved before it goes live.</a:t>
             </a:r>
           </a:p>
           <a:p>
@@ -4452,7 +4452,7 @@
                 </a:solidFill>
                 <a:latin typeface="Calibri"/>
               </a:rPr>
-              <a:t>Preview (dev)</a:t>
+              <a:t>Dev preview</a:t>
             </a:r>
           </a:p>
           <a:p>
@@ -4464,7 +4464,7 @@
                 </a:solidFill>
                 <a:latin typeface="Calibri"/>
               </a:rPr>
-              <a:t>check it looks right</a:t>
+              <a:t>review on the dev site</a:t>
             </a:r>
           </a:p>
         </p:txBody>
@@ -4571,7 +4571,7 @@
                 </a:solidFill>
                 <a:latin typeface="Calibri"/>
               </a:rPr>
-              <a:t>signs off</a:t>
+              <a:t>approves the preview</a:t>
             </a:r>
           </a:p>
         </p:txBody>
@@ -4678,7 +4678,7 @@
                 </a:solidFill>
                 <a:latin typeface="Calibri"/>
               </a:rPr>
-              <a:t>publishes to prod</a:t>
+              <a:t>publishes to live</a:t>
             </a:r>
           </a:p>
         </p:txBody>

</xml_diff>

<commit_message>
docs(comms): deck — clarify request folder is location-flexible; forms not templates
Fold Sandy's SharePoint clarification into the rollout deck (regenerated .pptx):

- Slide 5: "one shared folder" (not "one SharePoint area") + a subtitle noting it's a
  working folder in SharePoint/OneDrive/wherever agreed; footer names the saved form
  files (news-record.json / doc-record.json) instead of "filled template"; folder
  label "Open a form / guide from here".
- Slide 8/9: "visual news + document forms" and "shared request-folder package";
  next-step reads "set up the shared folder (SharePoint/OneDrive/wherever agreed)".

Verified: deck builds (10 slides, exit 0), no shape overflow.

Co-Authored-By: Claude Opus 4.8 (1M context) <noreply@anthropic.com>
Claude-Session: https://claude.ai/code/session_01C99BQqHqu8KProMCD4VQDd
</commit_message>
<xml_diff>
--- a/docs/COMMs-Website-Update-Workflow.pptx
+++ b/docs/COMMs-Website-Update-Workflow.pptx
@@ -5993,7 +5993,7 @@
         <p:spPr>
           <a:xfrm>
             <a:off x="548640" y="1280160"/>
-            <a:ext cx="10972800" cy="457200"/>
+            <a:ext cx="11338560" cy="457200"/>
           </a:xfrm>
           <a:prstGeom prst="rect">
             <a:avLst/>
@@ -6021,7 +6021,7 @@
                 </a:solidFill>
                 <a:latin typeface="Calibri"/>
               </a:rPr>
-              <a:t>Everything runs through one SharePoint area: </a:t>
+              <a:t>Everything runs through one shared folder: </a:t>
             </a:r>
             <a:r>
               <a:rPr sz="1600" b="1">
@@ -6037,58 +6037,14 @@
       </p:sp>
       <p:sp>
         <p:nvSpPr>
-          <p:cNvPr id="7" name="Rectangle 6"/>
-          <p:cNvSpPr/>
-          <p:nvPr/>
-        </p:nvSpPr>
-        <p:spPr>
-          <a:xfrm>
-            <a:off x="640080" y="2011680"/>
-            <a:ext cx="2926080" cy="640080"/>
-          </a:xfrm>
-          <a:prstGeom prst="rect">
-            <a:avLst/>
-          </a:prstGeom>
-          <a:solidFill>
-            <a:srgbClr val="5A5A5A"/>
-          </a:solidFill>
-          <a:ln>
-            <a:noFill/>
-          </a:ln>
-          <a:effectLst/>
-        </p:spPr>
-        <p:style>
-          <a:lnRef idx="1">
-            <a:schemeClr val="accent1"/>
-          </a:lnRef>
-          <a:fillRef idx="3">
-            <a:schemeClr val="accent1"/>
-          </a:fillRef>
-          <a:effectRef idx="2">
-            <a:schemeClr val="accent1"/>
-          </a:effectRef>
-          <a:fontRef idx="minor">
-            <a:schemeClr val="lt1"/>
-          </a:fontRef>
-        </p:style>
-        <p:txBody>
-          <a:bodyPr rtlCol="0" anchor="ctr"/>
-          <a:lstStyle/>
-          <a:p>
-            <a:pPr algn="ctr"/>
-          </a:p>
-        </p:txBody>
-      </p:sp>
-      <p:sp>
-        <p:nvSpPr>
-          <p:cNvPr id="8" name="TextBox 7"/>
+          <p:cNvPr id="7" name="TextBox 6"/>
           <p:cNvSpPr txBox="1"/>
           <p:nvPr/>
         </p:nvSpPr>
         <p:spPr>
           <a:xfrm>
-            <a:off x="640080" y="2011680"/>
-            <a:ext cx="2926080" cy="640080"/>
+            <a:off x="548640" y="1737360"/>
+            <a:ext cx="11338560" cy="365760"/>
           </a:xfrm>
           <a:prstGeom prst="rect">
             <a:avLst/>
@@ -6096,42 +6052,7 @@
           <a:noFill/>
         </p:spPr>
         <p:txBody>
-          <a:bodyPr wrap="none" anchor="ctr">
-            <a:spAutoFit/>
-          </a:bodyPr>
-          <a:lstStyle/>
-          <a:p>
-            <a:pPr algn="ctr"/>
-            <a:r>
-              <a:rPr b="1" sz="1500">
-                <a:solidFill>
-                  <a:srgbClr val="FFFFFF"/>
-                </a:solidFill>
-                <a:latin typeface="Calibri"/>
-              </a:rPr>
-              <a:t>_Templates</a:t>
-            </a:r>
-          </a:p>
-        </p:txBody>
-      </p:sp>
-      <p:sp>
-        <p:nvSpPr>
-          <p:cNvPr id="9" name="TextBox 8"/>
-          <p:cNvSpPr txBox="1"/>
-          <p:nvPr/>
-        </p:nvSpPr>
-        <p:spPr>
-          <a:xfrm>
-            <a:off x="3749039" y="2011680"/>
-            <a:ext cx="7315200" cy="640080"/>
-          </a:xfrm>
-          <a:prstGeom prst="rect">
-            <a:avLst/>
-          </a:prstGeom>
-          <a:noFill/>
-        </p:spPr>
-        <p:txBody>
-          <a:bodyPr wrap="square" anchor="ctr">
+          <a:bodyPr wrap="square" anchor="t">
             <a:spAutoFit/>
           </a:bodyPr>
           <a:lstStyle/>
@@ -6145,33 +6066,33 @@
               </a:spcAft>
             </a:pPr>
             <a:r>
-              <a:rPr sz="1400" b="0">
-                <a:solidFill>
-                  <a:srgbClr val="2B2B2B"/>
-                </a:solidFill>
-                <a:latin typeface="Calibri"/>
-              </a:rPr>
-              <a:t>Copy a template from here</a:t>
-            </a:r>
-          </a:p>
-        </p:txBody>
-      </p:sp>
-      <p:sp>
-        <p:nvSpPr>
-          <p:cNvPr id="10" name="Rectangle 9"/>
+              <a:rPr sz="1200" b="1">
+                <a:solidFill>
+                  <a:srgbClr val="5A5A5A"/>
+                </a:solidFill>
+                <a:latin typeface="Calibri"/>
+              </a:rPr>
+              <a:t>A working folder shared between COMMs and GDI — in SharePoint, OneDrive, or wherever both teams agree.</a:t>
+            </a:r>
+          </a:p>
+        </p:txBody>
+      </p:sp>
+      <p:sp>
+        <p:nvSpPr>
+          <p:cNvPr id="8" name="Rectangle 7"/>
           <p:cNvSpPr/>
           <p:nvPr/>
         </p:nvSpPr>
         <p:spPr>
           <a:xfrm>
-            <a:off x="640080" y="2788920"/>
+            <a:off x="640080" y="2011680"/>
             <a:ext cx="2926080" cy="640080"/>
           </a:xfrm>
           <a:prstGeom prst="rect">
             <a:avLst/>
           </a:prstGeom>
           <a:solidFill>
-            <a:srgbClr val="007A5E"/>
+            <a:srgbClr val="5A5A5A"/>
           </a:solidFill>
           <a:ln>
             <a:noFill/>
@@ -6202,13 +6123,13 @@
       </p:sp>
       <p:sp>
         <p:nvSpPr>
-          <p:cNvPr id="11" name="TextBox 10"/>
+          <p:cNvPr id="9" name="TextBox 8"/>
           <p:cNvSpPr txBox="1"/>
           <p:nvPr/>
         </p:nvSpPr>
         <p:spPr>
           <a:xfrm>
-            <a:off x="640080" y="2788920"/>
+            <a:off x="640080" y="2011680"/>
             <a:ext cx="2926080" cy="640080"/>
           </a:xfrm>
           <a:prstGeom prst="rect">
@@ -6230,20 +6151,20 @@
                 </a:solidFill>
                 <a:latin typeface="Calibri"/>
               </a:rPr>
-              <a:t>1-Submitted</a:t>
-            </a:r>
-          </a:p>
-        </p:txBody>
-      </p:sp>
-      <p:sp>
-        <p:nvSpPr>
-          <p:cNvPr id="12" name="TextBox 11"/>
+              <a:t>_Templates</a:t>
+            </a:r>
+          </a:p>
+        </p:txBody>
+      </p:sp>
+      <p:sp>
+        <p:nvSpPr>
+          <p:cNvPr id="10" name="TextBox 9"/>
           <p:cNvSpPr txBox="1"/>
           <p:nvPr/>
         </p:nvSpPr>
         <p:spPr>
           <a:xfrm>
-            <a:off x="3749039" y="2788920"/>
+            <a:off x="3749039" y="2011680"/>
             <a:ext cx="7315200" cy="640080"/>
           </a:xfrm>
           <a:prstGeom prst="rect">
@@ -6272,27 +6193,27 @@
                 </a:solidFill>
                 <a:latin typeface="Calibri"/>
               </a:rPr>
-              <a:t>You drop your request folder here</a:t>
-            </a:r>
-          </a:p>
-        </p:txBody>
-      </p:sp>
-      <p:sp>
-        <p:nvSpPr>
-          <p:cNvPr id="13" name="Rectangle 12"/>
+              <a:t>Open a form / guide from here</a:t>
+            </a:r>
+          </a:p>
+        </p:txBody>
+      </p:sp>
+      <p:sp>
+        <p:nvSpPr>
+          <p:cNvPr id="11" name="Rectangle 10"/>
           <p:cNvSpPr/>
           <p:nvPr/>
         </p:nvSpPr>
         <p:spPr>
           <a:xfrm>
-            <a:off x="640080" y="3566160"/>
+            <a:off x="640080" y="2788920"/>
             <a:ext cx="2926080" cy="640080"/>
           </a:xfrm>
           <a:prstGeom prst="rect">
             <a:avLst/>
           </a:prstGeom>
           <a:solidFill>
-            <a:srgbClr val="F2A900"/>
+            <a:srgbClr val="007A5E"/>
           </a:solidFill>
           <a:ln>
             <a:noFill/>
@@ -6323,13 +6244,13 @@
       </p:sp>
       <p:sp>
         <p:nvSpPr>
-          <p:cNvPr id="14" name="TextBox 13"/>
+          <p:cNvPr id="12" name="TextBox 11"/>
           <p:cNvSpPr txBox="1"/>
           <p:nvPr/>
         </p:nvSpPr>
         <p:spPr>
           <a:xfrm>
-            <a:off x="640080" y="3566160"/>
+            <a:off x="640080" y="2788920"/>
             <a:ext cx="2926080" cy="640080"/>
           </a:xfrm>
           <a:prstGeom prst="rect">
@@ -6347,24 +6268,24 @@
             <a:r>
               <a:rPr b="1" sz="1500">
                 <a:solidFill>
-                  <a:srgbClr val="2B2B2B"/>
-                </a:solidFill>
-                <a:latin typeface="Calibri"/>
-              </a:rPr>
-              <a:t>2-In-Progress</a:t>
-            </a:r>
-          </a:p>
-        </p:txBody>
-      </p:sp>
-      <p:sp>
-        <p:nvSpPr>
-          <p:cNvPr id="15" name="TextBox 14"/>
+                  <a:srgbClr val="FFFFFF"/>
+                </a:solidFill>
+                <a:latin typeface="Calibri"/>
+              </a:rPr>
+              <a:t>1-Submitted</a:t>
+            </a:r>
+          </a:p>
+        </p:txBody>
+      </p:sp>
+      <p:sp>
+        <p:nvSpPr>
+          <p:cNvPr id="13" name="TextBox 12"/>
           <p:cNvSpPr txBox="1"/>
           <p:nvPr/>
         </p:nvSpPr>
         <p:spPr>
           <a:xfrm>
-            <a:off x="3749039" y="3566160"/>
+            <a:off x="3749039" y="2788920"/>
             <a:ext cx="7315200" cy="640080"/>
           </a:xfrm>
           <a:prstGeom prst="rect">
@@ -6393,27 +6314,27 @@
                 </a:solidFill>
                 <a:latin typeface="Calibri"/>
               </a:rPr>
-              <a:t>GDI is working on it</a:t>
-            </a:r>
-          </a:p>
-        </p:txBody>
-      </p:sp>
-      <p:sp>
-        <p:nvSpPr>
-          <p:cNvPr id="16" name="Rectangle 15"/>
+              <a:t>You drop your request folder here</a:t>
+            </a:r>
+          </a:p>
+        </p:txBody>
+      </p:sp>
+      <p:sp>
+        <p:nvSpPr>
+          <p:cNvPr id="14" name="Rectangle 13"/>
           <p:cNvSpPr/>
           <p:nvPr/>
         </p:nvSpPr>
         <p:spPr>
           <a:xfrm>
-            <a:off x="640080" y="4343400"/>
+            <a:off x="640080" y="3566160"/>
             <a:ext cx="2926080" cy="640080"/>
           </a:xfrm>
           <a:prstGeom prst="rect">
             <a:avLst/>
           </a:prstGeom>
           <a:solidFill>
-            <a:srgbClr val="005340"/>
+            <a:srgbClr val="F2A900"/>
           </a:solidFill>
           <a:ln>
             <a:noFill/>
@@ -6444,13 +6365,13 @@
       </p:sp>
       <p:sp>
         <p:nvSpPr>
-          <p:cNvPr id="17" name="TextBox 16"/>
+          <p:cNvPr id="15" name="TextBox 14"/>
           <p:cNvSpPr txBox="1"/>
           <p:nvPr/>
         </p:nvSpPr>
         <p:spPr>
           <a:xfrm>
-            <a:off x="640080" y="4343400"/>
+            <a:off x="640080" y="3566160"/>
             <a:ext cx="2926080" cy="640080"/>
           </a:xfrm>
           <a:prstGeom prst="rect">
@@ -6468,24 +6389,24 @@
             <a:r>
               <a:rPr b="1" sz="1500">
                 <a:solidFill>
-                  <a:srgbClr val="FFFFFF"/>
-                </a:solidFill>
-                <a:latin typeface="Calibri"/>
-              </a:rPr>
-              <a:t>3-Done-Deployed</a:t>
-            </a:r>
-          </a:p>
-        </p:txBody>
-      </p:sp>
-      <p:sp>
-        <p:nvSpPr>
-          <p:cNvPr id="18" name="TextBox 17"/>
+                  <a:srgbClr val="2B2B2B"/>
+                </a:solidFill>
+                <a:latin typeface="Calibri"/>
+              </a:rPr>
+              <a:t>2-In-Progress</a:t>
+            </a:r>
+          </a:p>
+        </p:txBody>
+      </p:sp>
+      <p:sp>
+        <p:nvSpPr>
+          <p:cNvPr id="16" name="TextBox 15"/>
           <p:cNvSpPr txBox="1"/>
           <p:nvPr/>
         </p:nvSpPr>
         <p:spPr>
           <a:xfrm>
-            <a:off x="3749039" y="4343400"/>
+            <a:off x="3749039" y="3566160"/>
             <a:ext cx="7315200" cy="640080"/>
           </a:xfrm>
           <a:prstGeom prst="rect">
@@ -6514,7 +6435,86 @@
                 </a:solidFill>
                 <a:latin typeface="Calibri"/>
               </a:rPr>
-              <a:t>Live — with the links</a:t>
+              <a:t>GDI is working on it</a:t>
+            </a:r>
+          </a:p>
+        </p:txBody>
+      </p:sp>
+      <p:sp>
+        <p:nvSpPr>
+          <p:cNvPr id="17" name="Rectangle 16"/>
+          <p:cNvSpPr/>
+          <p:nvPr/>
+        </p:nvSpPr>
+        <p:spPr>
+          <a:xfrm>
+            <a:off x="640080" y="4343400"/>
+            <a:ext cx="2926080" cy="640080"/>
+          </a:xfrm>
+          <a:prstGeom prst="rect">
+            <a:avLst/>
+          </a:prstGeom>
+          <a:solidFill>
+            <a:srgbClr val="005340"/>
+          </a:solidFill>
+          <a:ln>
+            <a:noFill/>
+          </a:ln>
+          <a:effectLst/>
+        </p:spPr>
+        <p:style>
+          <a:lnRef idx="1">
+            <a:schemeClr val="accent1"/>
+          </a:lnRef>
+          <a:fillRef idx="3">
+            <a:schemeClr val="accent1"/>
+          </a:fillRef>
+          <a:effectRef idx="2">
+            <a:schemeClr val="accent1"/>
+          </a:effectRef>
+          <a:fontRef idx="minor">
+            <a:schemeClr val="lt1"/>
+          </a:fontRef>
+        </p:style>
+        <p:txBody>
+          <a:bodyPr rtlCol="0" anchor="ctr"/>
+          <a:lstStyle/>
+          <a:p>
+            <a:pPr algn="ctr"/>
+          </a:p>
+        </p:txBody>
+      </p:sp>
+      <p:sp>
+        <p:nvSpPr>
+          <p:cNvPr id="18" name="TextBox 17"/>
+          <p:cNvSpPr txBox="1"/>
+          <p:nvPr/>
+        </p:nvSpPr>
+        <p:spPr>
+          <a:xfrm>
+            <a:off x="640080" y="4343400"/>
+            <a:ext cx="2926080" cy="640080"/>
+          </a:xfrm>
+          <a:prstGeom prst="rect">
+            <a:avLst/>
+          </a:prstGeom>
+          <a:noFill/>
+        </p:spPr>
+        <p:txBody>
+          <a:bodyPr wrap="none" anchor="ctr">
+            <a:spAutoFit/>
+          </a:bodyPr>
+          <a:lstStyle/>
+          <a:p>
+            <a:pPr algn="ctr"/>
+            <a:r>
+              <a:rPr b="1" sz="1500">
+                <a:solidFill>
+                  <a:srgbClr val="FFFFFF"/>
+                </a:solidFill>
+                <a:latin typeface="Calibri"/>
+              </a:rPr>
+              <a:t>3-Done-Deployed</a:t>
             </a:r>
           </a:p>
         </p:txBody>
@@ -6527,8 +6527,8 @@
         </p:nvSpPr>
         <p:spPr>
           <a:xfrm>
-            <a:off x="640080" y="5394960"/>
-            <a:ext cx="10972800" cy="914400"/>
+            <a:off x="3749039" y="4343400"/>
+            <a:ext cx="7315200" cy="640080"/>
           </a:xfrm>
           <a:prstGeom prst="rect">
             <a:avLst/>
@@ -6536,7 +6536,7 @@
           <a:noFill/>
         </p:spPr>
         <p:txBody>
-          <a:bodyPr wrap="square" anchor="t">
+          <a:bodyPr wrap="square" anchor="ctr">
             <a:spAutoFit/>
           </a:bodyPr>
           <a:lstStyle/>
@@ -6550,33 +6550,38 @@
               </a:spcAft>
             </a:pPr>
             <a:r>
-              <a:rPr sz="1300" b="0">
-                <a:solidFill>
-                  <a:srgbClr val="5A5A5A"/>
-                </a:solidFill>
-                <a:latin typeface="Calibri"/>
-              </a:rPr>
-              <a:t>One folder per request, named  </a:t>
-            </a:r>
-            <a:r>
-              <a:rPr sz="1300" b="1">
-                <a:solidFill>
-                  <a:srgbClr val="007A5E"/>
-                </a:solidFill>
-                <a:latin typeface="Calibri"/>
-              </a:rPr>
-              <a:t>YYYY-MM-DD_type_short-name</a:t>
-            </a:r>
-            <a:r>
-              <a:rPr sz="1300" b="0">
-                <a:solidFill>
-                  <a:srgbClr val="5A5A5A"/>
-                </a:solidFill>
-                <a:latin typeface="Calibri"/>
-              </a:rPr>
-              <a:t>   (e.g. 2026-09-10_news_pkb-negotiation).</a:t>
-            </a:r>
-          </a:p>
+              <a:rPr sz="1400" b="0">
+                <a:solidFill>
+                  <a:srgbClr val="2B2B2B"/>
+                </a:solidFill>
+                <a:latin typeface="Calibri"/>
+              </a:rPr>
+              <a:t>Live — with the links</a:t>
+            </a:r>
+          </a:p>
+        </p:txBody>
+      </p:sp>
+      <p:sp>
+        <p:nvSpPr>
+          <p:cNvPr id="20" name="TextBox 19"/>
+          <p:cNvSpPr txBox="1"/>
+          <p:nvPr/>
+        </p:nvSpPr>
+        <p:spPr>
+          <a:xfrm>
+            <a:off x="640080" y="5394960"/>
+            <a:ext cx="10972800" cy="914400"/>
+          </a:xfrm>
+          <a:prstGeom prst="rect">
+            <a:avLst/>
+          </a:prstGeom>
+          <a:noFill/>
+        </p:spPr>
+        <p:txBody>
+          <a:bodyPr wrap="square" anchor="t">
+            <a:spAutoFit/>
+          </a:bodyPr>
+          <a:lstStyle/>
           <a:p>
             <a:pPr algn="l">
               <a:lnSpc>
@@ -6593,32 +6598,27 @@
                 </a:solidFill>
                 <a:latin typeface="Calibri"/>
               </a:rPr>
-              <a:t>Put the filled template + every image/PDF you reference inside that folder.</a:t>
-            </a:r>
-          </a:p>
-        </p:txBody>
-      </p:sp>
-      <p:sp>
-        <p:nvSpPr>
-          <p:cNvPr id="20" name="TextBox 19"/>
-          <p:cNvSpPr txBox="1"/>
-          <p:nvPr/>
-        </p:nvSpPr>
-        <p:spPr>
-          <a:xfrm>
-            <a:off x="457200" y="6446520"/>
-            <a:ext cx="7315200" cy="320040"/>
-          </a:xfrm>
-          <a:prstGeom prst="rect">
-            <a:avLst/>
-          </a:prstGeom>
-          <a:noFill/>
-        </p:spPr>
-        <p:txBody>
-          <a:bodyPr wrap="square" anchor="t">
-            <a:spAutoFit/>
-          </a:bodyPr>
-          <a:lstStyle/>
+              <a:t>One folder per request, named  </a:t>
+            </a:r>
+            <a:r>
+              <a:rPr sz="1300" b="1">
+                <a:solidFill>
+                  <a:srgbClr val="007A5E"/>
+                </a:solidFill>
+                <a:latin typeface="Calibri"/>
+              </a:rPr>
+              <a:t>YYYY-MM-DD_type_short-name</a:t>
+            </a:r>
+            <a:r>
+              <a:rPr sz="1300" b="0">
+                <a:solidFill>
+                  <a:srgbClr val="5A5A5A"/>
+                </a:solidFill>
+                <a:latin typeface="Calibri"/>
+              </a:rPr>
+              <a:t>   (e.g. 2026-09-10_news_pkb-negotiation).</a:t>
+            </a:r>
+          </a:p>
           <a:p>
             <a:pPr algn="l">
               <a:lnSpc>
@@ -6629,6 +6629,48 @@
               </a:spcAft>
             </a:pPr>
             <a:r>
+              <a:rPr sz="1300" b="0">
+                <a:solidFill>
+                  <a:srgbClr val="5A5A5A"/>
+                </a:solidFill>
+                <a:latin typeface="Calibri"/>
+              </a:rPr>
+              <a:t>Put the saved form file (news-record.json / doc-record.json) + every image/PDF inside that folder.</a:t>
+            </a:r>
+          </a:p>
+        </p:txBody>
+      </p:sp>
+      <p:sp>
+        <p:nvSpPr>
+          <p:cNvPr id="21" name="TextBox 20"/>
+          <p:cNvSpPr txBox="1"/>
+          <p:nvPr/>
+        </p:nvSpPr>
+        <p:spPr>
+          <a:xfrm>
+            <a:off x="457200" y="6446520"/>
+            <a:ext cx="7315200" cy="320040"/>
+          </a:xfrm>
+          <a:prstGeom prst="rect">
+            <a:avLst/>
+          </a:prstGeom>
+          <a:noFill/>
+        </p:spPr>
+        <p:txBody>
+          <a:bodyPr wrap="square" anchor="t">
+            <a:spAutoFit/>
+          </a:bodyPr>
+          <a:lstStyle/>
+          <a:p>
+            <a:pPr algn="l">
+              <a:lnSpc>
+                <a:spcPct val="100000"/>
+              </a:lnSpc>
+              <a:spcAft>
+                <a:spcPts val="400"/>
+              </a:spcAft>
+            </a:pPr>
+            <a:r>
               <a:rPr sz="900" b="0">
                 <a:solidFill>
                   <a:srgbClr val="5A5A5A"/>
@@ -6642,7 +6684,7 @@
       </p:sp>
       <p:sp>
         <p:nvSpPr>
-          <p:cNvPr id="21" name="TextBox 20"/>
+          <p:cNvPr id="22" name="TextBox 21"/>
           <p:cNvSpPr txBox="1"/>
           <p:nvPr/>
         </p:nvSpPr>
@@ -8767,7 +8809,7 @@
                 </a:solidFill>
                 <a:latin typeface="Calibri"/>
               </a:rPr>
-              <a:t>•  Request tools built: news converter + new-page content extract/inject.</a:t>
+              <a:t>•  Request tools built: visual news + document forms, new-page content extract/inject.</a:t>
             </a:r>
           </a:p>
           <a:p>
@@ -8786,7 +8828,7 @@
                 </a:solidFill>
                 <a:latin typeface="Calibri"/>
               </a:rPr>
-              <a:t>•  SharePoint request folders + templates + guides ready to go.</a:t>
+              <a:t>•  Shared request-folder package (forms + guides) ready to go.</a:t>
             </a:r>
           </a:p>
         </p:txBody>
@@ -9102,7 +9144,7 @@
                 </a:solidFill>
                 <a:latin typeface="Calibri"/>
               </a:rPr>
-              <a:t>•  IT/GDI: create the SharePoint Website-Update-Requests area (package is ready to upload).</a:t>
+              <a:t>•  IT/GDI: set up the shared Website-Update-Requests folder (SharePoint/OneDrive/wherever agreed — package is ready to upload).</a:t>
             </a:r>
           </a:p>
           <a:p>

</xml_diff>